<commit_message>
Reframe deck as a generic local AI voice system; add pitch script and Q&A
- Deck: lead with "a local AI voice system" and demote translation to one
  capability among several (captions, notes/tasks, commands, translation,
  agents); generalize the problem and solution slides accordingly.
- Add Presentation/PITCH_SCRIPT_2MIN.md (2-minute narration over the deck).
- Add Presentation/QA.md (answers to the submission questions).

Co-Authored-By: Claude Opus 4.8 <noreply@anthropic.com>
</commit_message>
<xml_diff>
--- a/Presentation/LocoCisco_Presentation.pptx
+++ b/Presentation/LocoCisco_Presentation.pptx
@@ -1842,7 +1842,7 @@
                 <a:ea typeface="Calibri" pitchFamily="34" charset="-122"/>
                 <a:cs typeface="Calibri" pitchFamily="34" charset="-120"/>
               </a:rPr>
-              <a:t>LOCAL-FIRST CONVERSATION INTELLIGENCE</a:t>
+              <a:t>A LOCAL AI VOICE SYSTEM</a:t>
             </a:r>
             <a:endParaRPr lang="en-US" sz="1400" dirty="0"/>
           </a:p>
@@ -1920,7 +1920,7 @@
                 <a:ea typeface="Calibri" pitchFamily="34" charset="-122"/>
                 <a:cs typeface="Calibri" pitchFamily="34" charset="-120"/>
               </a:rPr>
-              <a:t>Conversation intelligence that stays where you need it</a:t>
+              <a:t>Voice AI that runs entirely on your own hardware</a:t>
             </a:r>
             <a:endParaRPr lang="en-US" sz="2300" dirty="0"/>
           </a:p>
@@ -1959,7 +1959,7 @@
                 <a:ea typeface="Calibri" pitchFamily="34" charset="-122"/>
                 <a:cs typeface="Calibri" pitchFamily="34" charset="-120"/>
               </a:rPr>
-              <a:t>Understands the room, captures what matters, and controls what leaves — on your own hardware.</a:t>
+              <a:t>Understands speech, turns it into action, and controls what leaves — nothing is sent to the cloud.</a:t>
             </a:r>
             <a:endParaRPr lang="en-US" sz="1400" dirty="0"/>
           </a:p>
@@ -4602,7 +4602,7 @@
                 <a:ea typeface="Cambria" pitchFamily="34" charset="-122"/>
                 <a:cs typeface="Cambria" pitchFamily="34" charset="-120"/>
               </a:rPr>
-              <a:t>Service happens out loud — and it’s sensitive</a:t>
+              <a:t>Voice is everywhere — today’s AI sends it away</a:t>
             </a:r>
             <a:endParaRPr lang="en-US" sz="3200" dirty="0"/>
           </a:p>
@@ -4719,7 +4719,7 @@
                 <a:ea typeface="Cambria" pitchFamily="34" charset="-122"/>
                 <a:cs typeface="Cambria" pitchFamily="34" charset="-120"/>
               </a:rPr>
-              <a:t>Sensitive by default</a:t>
+              <a:t>Your audio leaves</a:t>
             </a:r>
             <a:endParaRPr lang="en-US" sz="1800" dirty="0"/>
           </a:p>
@@ -4758,7 +4758,7 @@
                 <a:ea typeface="Calibri" pitchFamily="34" charset="-122"/>
                 <a:cs typeface="Calibri" pitchFamily="34" charset="-120"/>
               </a:rPr>
-              <a:t>Names, payments, health, case files, evidence — cloud AI ships it off-site, where it can’t go.</a:t>
+              <a:t>Cloud voice AI ships sensitive speech off-site — names, payments, health, case files, evidence — where it can’t go.</a:t>
             </a:r>
             <a:endParaRPr lang="en-US" sz="1350" dirty="0"/>
           </a:p>
@@ -4875,7 +4875,7 @@
                 <a:ea typeface="Cambria" pitchFamily="34" charset="-122"/>
                 <a:cs typeface="Cambria" pitchFamily="34" charset="-120"/>
               </a:rPr>
-              <a:t>Language barriers everywhere</a:t>
+              <a:t>Cloud-bound and slow</a:t>
             </a:r>
             <a:endParaRPr lang="en-US" sz="1800" dirty="0"/>
           </a:p>
@@ -4914,7 +4914,7 @@
                 <a:ea typeface="Calibri" pitchFamily="34" charset="-122"/>
                 <a:cs typeface="Calibri" pitchFamily="34" charset="-120"/>
               </a:rPr>
-              <a:t>Guests, residents and the public rarely speak one language; interpreters are slow and costly.</a:t>
+              <a:t>A network round-trip on every request; it stalls or fails when connectivity is weak or gone.</a:t>
             </a:r>
             <a:endParaRPr lang="en-US" sz="1350" dirty="0"/>
           </a:p>
@@ -5031,7 +5031,7 @@
                 <a:ea typeface="Cambria" pitchFamily="34" charset="-122"/>
                 <a:cs typeface="Cambria" pitchFamily="34" charset="-120"/>
               </a:rPr>
-              <a:t>Nothing gets captured</a:t>
+              <a:t>Speech is lost</a:t>
             </a:r>
             <a:endParaRPr lang="en-US" sz="1800" dirty="0"/>
           </a:p>
@@ -5070,7 +5070,7 @@
                 <a:ea typeface="Calibri" pitchFamily="34" charset="-122"/>
                 <a:cs typeface="Calibri" pitchFamily="34" charset="-120"/>
               </a:rPr>
-              <a:t>Requests, promises and decisions live in people’s heads — no record, no follow-through.</a:t>
+              <a:t>What’s said — requests, decisions, commands — rarely turns into action or a record.</a:t>
             </a:r>
             <a:endParaRPr lang="en-US" sz="1350" dirty="0"/>
           </a:p>
@@ -5109,7 +5109,7 @@
                 <a:ea typeface="Calibri" pitchFamily="34" charset="-122"/>
                 <a:cs typeface="Calibri" pitchFamily="34" charset="-120"/>
               </a:rPr>
-              <a:t>Front-line staff handle this dozens of times a day — with tools that either leak the data or don’t understand the room.</a:t>
+              <a:t>People talk all day. The understanding should stay with them — private, instant, and captured — not shipped to someone else’s cloud.</a:t>
             </a:r>
             <a:endParaRPr lang="en-US" sz="1400" dirty="0"/>
           </a:p>
@@ -5258,7 +5258,7 @@
                 <a:ea typeface="Cambria" pitchFamily="34" charset="-122"/>
                 <a:cs typeface="Cambria" pitchFamily="34" charset="-120"/>
               </a:rPr>
-              <a:t>LocoCisco understands the room — locally</a:t>
+              <a:t>A local AI voice system</a:t>
             </a:r>
             <a:endParaRPr lang="en-US" sz="3200" dirty="0"/>
           </a:p>
@@ -5297,7 +5297,7 @@
                 <a:ea typeface="Calibri" pitchFamily="34" charset="-122"/>
                 <a:cs typeface="Calibri" pitchFamily="34" charset="-120"/>
               </a:rPr>
-              <a:t>Listens without a wake word, understands multi-speaker conversation on local hardware, captures tasks and decisions, and controls exactly what leaves the room.</a:t>
+              <a:t>LocoCisco listens, understands who said what, and turns speech into action — all on your own hardware, with nothing sent to the cloud.</a:t>
             </a:r>
             <a:endParaRPr lang="en-US" sz="1600" dirty="0"/>
           </a:p>
@@ -5311,12 +5311,12 @@
         </p:nvSpPr>
         <p:spPr>
           <a:xfrm>
-            <a:off x="548640" y="2148840"/>
-            <a:ext cx="3429000" cy="2834640"/>
+            <a:off x="548640" y="2057400"/>
+            <a:ext cx="3429000" cy="2743200"/>
           </a:xfrm>
           <a:prstGeom prst="roundRect">
             <a:avLst>
-              <a:gd name="adj" fmla="val 2903"/>
+              <a:gd name="adj" fmla="val 3000"/>
             </a:avLst>
           </a:prstGeom>
           <a:solidFill>
@@ -5345,7 +5345,7 @@
         </p:nvSpPr>
         <p:spPr>
           <a:xfrm>
-            <a:off x="868680" y="2514600"/>
+            <a:off x="868680" y="2423160"/>
             <a:ext cx="914400" cy="914400"/>
           </a:xfrm>
           <a:prstGeom prst="ellipse">
@@ -5373,7 +5373,7 @@
         </p:blipFill>
         <p:spPr>
           <a:xfrm>
-            <a:off x="1124712" y="2770632"/>
+            <a:off x="1124712" y="2679192"/>
             <a:ext cx="402336" cy="402336"/>
           </a:xfrm>
           <a:prstGeom prst="rect">
@@ -5389,7 +5389,7 @@
         </p:nvSpPr>
         <p:spPr>
           <a:xfrm>
-            <a:off x="868680" y="3566160"/>
+            <a:off x="868680" y="3429000"/>
             <a:ext cx="2788920" cy="457200"/>
           </a:xfrm>
           <a:prstGeom prst="rect">
@@ -5428,7 +5428,7 @@
         </p:nvSpPr>
         <p:spPr>
           <a:xfrm>
-            <a:off x="868680" y="4023360"/>
+            <a:off x="868680" y="3886200"/>
             <a:ext cx="2788920" cy="868680"/>
           </a:xfrm>
           <a:prstGeom prst="rect">
@@ -5467,12 +5467,12 @@
         </p:nvSpPr>
         <p:spPr>
           <a:xfrm>
-            <a:off x="4343400" y="2148840"/>
-            <a:ext cx="3429000" cy="2834640"/>
+            <a:off x="4343400" y="2057400"/>
+            <a:ext cx="3429000" cy="2743200"/>
           </a:xfrm>
           <a:prstGeom prst="roundRect">
             <a:avLst>
-              <a:gd name="adj" fmla="val 2903"/>
+              <a:gd name="adj" fmla="val 3000"/>
             </a:avLst>
           </a:prstGeom>
           <a:solidFill>
@@ -5501,7 +5501,7 @@
         </p:nvSpPr>
         <p:spPr>
           <a:xfrm>
-            <a:off x="4663440" y="2514600"/>
+            <a:off x="4663440" y="2423160"/>
             <a:ext cx="914400" cy="914400"/>
           </a:xfrm>
           <a:prstGeom prst="ellipse">
@@ -5529,7 +5529,7 @@
         </p:blipFill>
         <p:spPr>
           <a:xfrm>
-            <a:off x="4919472" y="2770632"/>
+            <a:off x="4919472" y="2679192"/>
             <a:ext cx="402336" cy="402336"/>
           </a:xfrm>
           <a:prstGeom prst="rect">
@@ -5545,7 +5545,7 @@
         </p:nvSpPr>
         <p:spPr>
           <a:xfrm>
-            <a:off x="4663440" y="3566160"/>
+            <a:off x="4663440" y="3429000"/>
             <a:ext cx="2788920" cy="457200"/>
           </a:xfrm>
           <a:prstGeom prst="rect">
@@ -5570,7 +5570,7 @@
                 <a:ea typeface="Cambria" pitchFamily="34" charset="-122"/>
                 <a:cs typeface="Cambria" pitchFamily="34" charset="-120"/>
               </a:rPr>
-              <a:t>Multilingual</a:t>
+              <a:t>Real-time voice</a:t>
             </a:r>
             <a:endParaRPr lang="en-US" sz="1800" dirty="0"/>
           </a:p>
@@ -5584,7 +5584,7 @@
         </p:nvSpPr>
         <p:spPr>
           <a:xfrm>
-            <a:off x="4663440" y="4023360"/>
+            <a:off x="4663440" y="3886200"/>
             <a:ext cx="2788920" cy="868680"/>
           </a:xfrm>
           <a:prstGeom prst="rect">
@@ -5609,7 +5609,7 @@
                 <a:ea typeface="Calibri" pitchFamily="34" charset="-122"/>
                 <a:cs typeface="Calibri" pitchFamily="34" charset="-120"/>
               </a:rPr>
-              <a:t>Transcribes and translates on-site, so staff and customers understand each other.</a:t>
+              <a:t>Wake-word-free speech recognition and speaker attribution, understood the instant people talk.</a:t>
             </a:r>
             <a:endParaRPr lang="en-US" sz="1350" dirty="0"/>
           </a:p>
@@ -5623,12 +5623,12 @@
         </p:nvSpPr>
         <p:spPr>
           <a:xfrm>
-            <a:off x="8138160" y="2148840"/>
-            <a:ext cx="3429000" cy="2834640"/>
+            <a:off x="8138160" y="2057400"/>
+            <a:ext cx="3429000" cy="2743200"/>
           </a:xfrm>
           <a:prstGeom prst="roundRect">
             <a:avLst>
-              <a:gd name="adj" fmla="val 2903"/>
+              <a:gd name="adj" fmla="val 3000"/>
             </a:avLst>
           </a:prstGeom>
           <a:solidFill>
@@ -5657,7 +5657,7 @@
         </p:nvSpPr>
         <p:spPr>
           <a:xfrm>
-            <a:off x="8458200" y="2514600"/>
+            <a:off x="8458200" y="2423160"/>
             <a:ext cx="914400" cy="914400"/>
           </a:xfrm>
           <a:prstGeom prst="ellipse">
@@ -5685,7 +5685,7 @@
         </p:blipFill>
         <p:spPr>
           <a:xfrm>
-            <a:off x="8714232" y="2770632"/>
+            <a:off x="8714232" y="2679192"/>
             <a:ext cx="402336" cy="402336"/>
           </a:xfrm>
           <a:prstGeom prst="rect">
@@ -5701,7 +5701,7 @@
         </p:nvSpPr>
         <p:spPr>
           <a:xfrm>
-            <a:off x="8458200" y="3566160"/>
+            <a:off x="8458200" y="3429000"/>
             <a:ext cx="2788920" cy="457200"/>
           </a:xfrm>
           <a:prstGeom prst="rect">
@@ -5726,7 +5726,7 @@
                 <a:ea typeface="Cambria" pitchFamily="34" charset="-122"/>
                 <a:cs typeface="Cambria" pitchFamily="34" charset="-120"/>
               </a:rPr>
-              <a:t>Actionable record</a:t>
+              <a:t>Voice into action</a:t>
             </a:r>
             <a:endParaRPr lang="en-US" sz="1800" dirty="0"/>
           </a:p>
@@ -5740,7 +5740,7 @@
         </p:nvSpPr>
         <p:spPr>
           <a:xfrm>
-            <a:off x="8458200" y="4023360"/>
+            <a:off x="8458200" y="3886200"/>
             <a:ext cx="2788920" cy="868680"/>
           </a:xfrm>
           <a:prstGeom prst="rect">
@@ -5765,7 +5765,7 @@
                 <a:ea typeface="Calibri" pitchFamily="34" charset="-122"/>
                 <a:cs typeface="Calibri" pitchFamily="34" charset="-120"/>
               </a:rPr>
-              <a:t>Turns every interaction into attributed tasks, decisions and follow-ups.</a:t>
+              <a:t>Turns speech into tasks, decisions, commands and records — not just a transcript.</a:t>
             </a:r>
             <a:endParaRPr lang="en-US" sz="1350" dirty="0"/>
           </a:p>
@@ -5774,6 +5774,59 @@
       <p:sp>
         <p:nvSpPr>
           <p:cNvPr id="20" name="Text 15"/>
+          <p:cNvSpPr txBox="1"/>
+          <p:nvPr/>
+        </p:nvSpPr>
+        <p:spPr>
+          <a:xfrm>
+            <a:off x="548640" y="5074920"/>
+            <a:ext cx="11064240" cy="457200"/>
+          </a:xfrm>
+          <a:prstGeom prst="rect">
+            <a:avLst/>
+          </a:prstGeom>
+          <a:noFill/>
+          <a:ln/>
+        </p:spPr>
+        <p:txBody>
+          <a:bodyPr wrap="square" rtlCol="0" anchor="ctr"/>
+          <a:lstStyle/>
+          <a:p>
+            <a:pPr algn="ctr" indent="0" marL="0">
+              <a:buNone/>
+            </a:pPr>
+            <a:r>
+              <a:rPr lang="en-US" sz="1400" b="1" dirty="0">
+                <a:solidFill>
+                  <a:srgbClr val="1A2234"/>
+                </a:solidFill>
+                <a:latin typeface="Calibri" pitchFamily="34" charset="0"/>
+                <a:ea typeface="Calibri" pitchFamily="34" charset="-122"/>
+                <a:cs typeface="Calibri" pitchFamily="34" charset="-120"/>
+              </a:rPr>
+              <a:t>One system, many jobs:  </a:t>
+            </a:r>
+            <a:pPr algn="ctr" indent="0" marL="0">
+              <a:buNone/>
+            </a:pPr>
+            <a:r>
+              <a:rPr lang="en-US" sz="1400" dirty="0">
+                <a:solidFill>
+                  <a:srgbClr val="5C6879"/>
+                </a:solidFill>
+                <a:latin typeface="Calibri" pitchFamily="34" charset="0"/>
+                <a:ea typeface="Calibri" pitchFamily="34" charset="-122"/>
+                <a:cs typeface="Calibri" pitchFamily="34" charset="-120"/>
+              </a:rPr>
+              <a:t>live captions · meeting notes &amp; tasks · voice commands · translation · agent actions.</a:t>
+            </a:r>
+            <a:endParaRPr lang="en-US" sz="1400" dirty="0"/>
+          </a:p>
+        </p:txBody>
+      </p:sp>
+      <p:sp>
+        <p:nvSpPr>
+          <p:cNvPr id="21" name="Text 16"/>
           <p:cNvSpPr txBox="1"/>
           <p:nvPr/>
         </p:nvSpPr>
@@ -6911,7 +6964,7 @@
                 <a:ea typeface="Calibri" pitchFamily="34" charset="-122"/>
                 <a:cs typeface="Calibri" pitchFamily="34" charset="-120"/>
               </a:rPr>
-              <a:t>The deterministic policy gate runs before anything is posted or any device acts — no cloud round-trip for the content or the translation. Captions, decisions and recording keep working with no internet.</a:t>
+              <a:t>The deterministic policy gate runs before anything is posted or any device acts — no cloud round-trip for any inference. Everything — captions, decisions, actions — keeps working with no internet.</a:t>
             </a:r>
             <a:endParaRPr lang="en-US" sz="1400" dirty="0"/>
           </a:p>
@@ -7879,7 +7932,7 @@
                 <a:ea typeface="Calibri" pitchFamily="34" charset="-122"/>
                 <a:cs typeface="Calibri" pitchFamily="34" charset="-120"/>
               </a:rPr>
-              <a:t>Near term — wherever people serve people and the conversation is sensitive: serve them in their language, keep content on-site, never lose the follow-up.</a:t>
+              <a:t>Near term — wherever people talk and decisions happen: understand every interaction, act on it, and keep it on-site.</a:t>
             </a:r>
             <a:endParaRPr lang="en-US" sz="1400" dirty="0"/>
           </a:p>

</xml_diff>